<commit_message>
Log Background App Refresh status at launch to diagnose Calendar Scanning dead zones
</commit_message>
<xml_diff>
--- a/docs/GeoNap Presentations/GeoNap_Marketing_Deck.pptx
+++ b/docs/GeoNap Presentations/GeoNap_Marketing_Deck.pptx
@@ -320,7 +320,7 @@
           <a:p>
             <a:fld id="{5BCAD085-E8A6-8845-BD4E-CB4CCA059FC4}" type="datetimeFigureOut">
               <a:rPr lang="en-US" smtClean="0"/>
-              <a:t>8/6/26</a:t>
+              <a:t>9/16/26</a:t>
             </a:fld>
             <a:endParaRPr lang="en-US"/>
           </a:p>
@@ -488,7 +488,7 @@
           <a:p>
             <a:fld id="{5BCAD085-E8A6-8845-BD4E-CB4CCA059FC4}" type="datetimeFigureOut">
               <a:rPr lang="en-US" smtClean="0"/>
-              <a:t>8/6/26</a:t>
+              <a:t>9/16/26</a:t>
             </a:fld>
             <a:endParaRPr lang="en-US"/>
           </a:p>
@@ -666,7 +666,7 @@
           <a:p>
             <a:fld id="{5BCAD085-E8A6-8845-BD4E-CB4CCA059FC4}" type="datetimeFigureOut">
               <a:rPr lang="en-US" smtClean="0"/>
-              <a:t>8/6/26</a:t>
+              <a:t>9/16/26</a:t>
             </a:fld>
             <a:endParaRPr lang="en-US"/>
           </a:p>
@@ -834,7 +834,7 @@
           <a:p>
             <a:fld id="{5BCAD085-E8A6-8845-BD4E-CB4CCA059FC4}" type="datetimeFigureOut">
               <a:rPr lang="en-US" smtClean="0"/>
-              <a:t>8/6/26</a:t>
+              <a:t>9/16/26</a:t>
             </a:fld>
             <a:endParaRPr lang="en-US"/>
           </a:p>
@@ -1079,7 +1079,7 @@
           <a:p>
             <a:fld id="{5BCAD085-E8A6-8845-BD4E-CB4CCA059FC4}" type="datetimeFigureOut">
               <a:rPr lang="en-US" smtClean="0"/>
-              <a:t>8/6/26</a:t>
+              <a:t>9/16/26</a:t>
             </a:fld>
             <a:endParaRPr lang="en-US"/>
           </a:p>
@@ -1364,7 +1364,7 @@
           <a:p>
             <a:fld id="{5BCAD085-E8A6-8845-BD4E-CB4CCA059FC4}" type="datetimeFigureOut">
               <a:rPr lang="en-US" smtClean="0"/>
-              <a:t>8/6/26</a:t>
+              <a:t>9/16/26</a:t>
             </a:fld>
             <a:endParaRPr lang="en-US"/>
           </a:p>
@@ -1783,7 +1783,7 @@
           <a:p>
             <a:fld id="{5BCAD085-E8A6-8845-BD4E-CB4CCA059FC4}" type="datetimeFigureOut">
               <a:rPr lang="en-US" smtClean="0"/>
-              <a:t>8/6/26</a:t>
+              <a:t>9/16/26</a:t>
             </a:fld>
             <a:endParaRPr lang="en-US"/>
           </a:p>
@@ -1900,7 +1900,7 @@
           <a:p>
             <a:fld id="{5BCAD085-E8A6-8845-BD4E-CB4CCA059FC4}" type="datetimeFigureOut">
               <a:rPr lang="en-US" smtClean="0"/>
-              <a:t>8/6/26</a:t>
+              <a:t>9/16/26</a:t>
             </a:fld>
             <a:endParaRPr lang="en-US"/>
           </a:p>
@@ -1995,7 +1995,7 @@
           <a:p>
             <a:fld id="{5BCAD085-E8A6-8845-BD4E-CB4CCA059FC4}" type="datetimeFigureOut">
               <a:rPr lang="en-US" smtClean="0"/>
-              <a:t>8/6/26</a:t>
+              <a:t>9/16/26</a:t>
             </a:fld>
             <a:endParaRPr lang="en-US"/>
           </a:p>
@@ -2270,7 +2270,7 @@
           <a:p>
             <a:fld id="{5BCAD085-E8A6-8845-BD4E-CB4CCA059FC4}" type="datetimeFigureOut">
               <a:rPr lang="en-US" smtClean="0"/>
-              <a:t>8/6/26</a:t>
+              <a:t>9/16/26</a:t>
             </a:fld>
             <a:endParaRPr lang="en-US"/>
           </a:p>
@@ -2522,7 +2522,7 @@
           <a:p>
             <a:fld id="{5BCAD085-E8A6-8845-BD4E-CB4CCA059FC4}" type="datetimeFigureOut">
               <a:rPr lang="en-US" smtClean="0"/>
-              <a:t>8/6/26</a:t>
+              <a:t>9/16/26</a:t>
             </a:fld>
             <a:endParaRPr lang="en-US"/>
           </a:p>
@@ -2733,7 +2733,7 @@
           <a:p>
             <a:fld id="{5BCAD085-E8A6-8845-BD4E-CB4CCA059FC4}" type="datetimeFigureOut">
               <a:rPr lang="en-US" smtClean="0"/>
-              <a:t>8/6/26</a:t>
+              <a:t>9/16/26</a:t>
             </a:fld>
             <a:endParaRPr lang="en-US"/>
           </a:p>
@@ -3809,7 +3809,7 @@
                 </a:solidFill>
                 <a:latin typeface="Calibri"/>
               </a:rPr>
-              <a:t>1.145-20260712</a:t>
+              <a:t>1.180-20260911</a:t>
             </a:r>
             <a:endParaRPr sz="1150" b="1" i="0" dirty="0">
               <a:solidFill>
@@ -8819,7 +8819,7 @@
         </p:nvGraphicFramePr>
         <p:xfrm>
           <a:off x="548640" y="1700000"/>
-          <a:ext cx="11091672" cy="4484012"/>
+          <a:ext cx="11091672" cy="4669432"/>
         </p:xfrm>
         <a:graphic>
           <a:graphicData uri="http://schemas.openxmlformats.org/drawingml/2006/table">
@@ -8858,6 +8858,7 @@
                         </a:defRPr>
                       </a:pPr>
                       <a:r>
+                        <a:rPr dirty="0"/>
                         <a:t>Plan</a:t>
                       </a:r>
                     </a:p>
@@ -9445,34 +9446,16 @@
                           </a:solidFill>
                           <a:latin typeface="Calibri"/>
                         </a:rPr>
-                        <a:t>Everything </a:t>
+                        <a:t>Everything in </a:t>
                       </a:r>
                       <a:r>
-                        <a:rPr sz="1050" b="1" i="1">
+                        <a:rPr lang="en-US" sz="1050" b="1" i="1" dirty="0">
                           <a:solidFill>
                             <a:srgbClr val="5C7182"/>
                           </a:solidFill>
                           <a:latin typeface="Calibri"/>
                         </a:rPr>
-                        <a:t>in </a:t>
-                      </a:r>
-                      <a:r>
-                        <a:rPr lang="en-US" sz="1050" b="1" i="1">
-                          <a:solidFill>
-                            <a:srgbClr val="5C7182"/>
-                          </a:solidFill>
-                          <a:latin typeface="Calibri"/>
-                        </a:rPr>
-                        <a:t>Glod</a:t>
-                      </a:r>
-                      <a:r>
-                        <a:rPr sz="1050" b="1" i="1">
-                          <a:solidFill>
-                            <a:srgbClr val="5C7182"/>
-                          </a:solidFill>
-                          <a:latin typeface="Calibri"/>
-                        </a:rPr>
-                        <a:t>, </a:t>
+                        <a:t>Gold</a:t>
                       </a:r>
                       <a:r>
                         <a:rPr sz="1050" b="1" i="1" dirty="0">
@@ -9481,7 +9464,7 @@
                           </a:solidFill>
                           <a:latin typeface="Calibri"/>
                         </a:rPr>
-                        <a:t>plus:</a:t>
+                        <a:t>, plus:</a:t>
                       </a:r>
                     </a:p>
                     <a:p>
@@ -9616,6 +9599,24 @@
                         </a:solidFill>
                         <a:latin typeface="Calibri"/>
                       </a:endParaRPr>
+                    </a:p>
+                    <a:p>
+                      <a:pPr marL="171450" indent="-171450">
+                        <a:spcAft>
+                          <a:spcPts val="150"/>
+                        </a:spcAft>
+                        <a:buFont typeface="Arial"/>
+                        <a:buChar char="•"/>
+                      </a:pPr>
+                      <a:r>
+                        <a:rPr sz="1050" b="0" dirty="0">
+                          <a:solidFill>
+                            <a:srgbClr val="17303F"/>
+                          </a:solidFill>
+                          <a:latin typeface="Calibri"/>
+                        </a:rPr>
+                        <a:t>Family Sharing included — one purchase covers your whole family</a:t>
+                      </a:r>
                     </a:p>
                   </a:txBody>
                   <a:tcPr marL="109728" marT="73152" marB="73152" anchor="ctr">

</xml_diff>